<commit_message>
Deploying to gh-pages from @ tamanh-oxford/capacity-development@d4e0450d65abaea32b3ef9f8ebc4ae358e7f7ed4 🚀
</commit_message>
<xml_diff>
--- a/vi/data-frameworks/11-best-practice-capacity-building.pptx
+++ b/vi/data-frameworks/11-best-practice-capacity-building.pptx
@@ -3727,7 +3727,7 @@
             </a:r>
             <a:r>
               <a:rPr/>
-              <a:t>Ứng dụng, Dữ liệu, Lãnh đạo, Văn hóa, Công cụ, Kỹ năng</a:t>
+              <a:t> Ứng dụng, Dữ liệu, Lãnh đạo, Văn hóa, Công cụ, Kỹ năng</a:t>
             </a:r>
           </a:p>
           <a:p>
@@ -3738,7 +3738,7 @@
             </a:r>
             <a:r>
               <a:rPr/>
-              <a:t>Bắt đầu, Phát triển ban đầu, Học hỏi, Phát triển, Thành thạo</a:t>
+              <a:t> Bắt đầu, Phát triển ban đầu, Học hỏi, Phát triển, Thành thạo</a:t>
             </a:r>
           </a:p>
           <a:p>

</xml_diff>